<commit_message>
Eindpresentatie op locatie gemaakt
</commit_message>
<xml_diff>
--- a/Presentaties/Template Sprint Reviews.pptx
+++ b/Presentaties/Template Sprint Reviews.pptx
@@ -3641,7 +3641,7 @@
           <a:p>
             <a:fld id="{4A37A092-F479-4C17-8DAB-26C19D8DEF50}" type="datetimeFigureOut">
               <a:rPr lang="nl-NL" smtClean="0"/>
-              <a:t>28-11-2025</a:t>
+              <a:t>13-2-2026</a:t>
             </a:fld>
             <a:endParaRPr lang="nl-NL"/>
           </a:p>
@@ -3975,7 +3975,7 @@
           <a:p>
             <a:fld id="{4A37A092-F479-4C17-8DAB-26C19D8DEF50}" type="datetimeFigureOut">
               <a:rPr lang="nl-NL" smtClean="0"/>
-              <a:t>28-11-2025</a:t>
+              <a:t>13-2-2026</a:t>
             </a:fld>
             <a:endParaRPr lang="nl-NL"/>
           </a:p>
@@ -4253,7 +4253,7 @@
           <a:p>
             <a:fld id="{4A37A092-F479-4C17-8DAB-26C19D8DEF50}" type="datetimeFigureOut">
               <a:rPr lang="nl-NL" smtClean="0"/>
-              <a:t>28-11-2025</a:t>
+              <a:t>13-2-2026</a:t>
             </a:fld>
             <a:endParaRPr lang="nl-NL"/>
           </a:p>
@@ -4821,7 +4821,7 @@
           <a:p>
             <a:fld id="{4A37A092-F479-4C17-8DAB-26C19D8DEF50}" type="datetimeFigureOut">
               <a:rPr lang="nl-NL" smtClean="0"/>
-              <a:t>28-11-2025</a:t>
+              <a:t>13-2-2026</a:t>
             </a:fld>
             <a:endParaRPr lang="nl-NL"/>
           </a:p>
@@ -5099,7 +5099,7 @@
           <a:p>
             <a:fld id="{4A37A092-F479-4C17-8DAB-26C19D8DEF50}" type="datetimeFigureOut">
               <a:rPr lang="nl-NL" smtClean="0"/>
-              <a:t>28-11-2025</a:t>
+              <a:t>13-2-2026</a:t>
             </a:fld>
             <a:endParaRPr lang="nl-NL"/>
           </a:p>
@@ -5661,7 +5661,7 @@
           <a:p>
             <a:fld id="{4A37A092-F479-4C17-8DAB-26C19D8DEF50}" type="datetimeFigureOut">
               <a:rPr lang="nl-NL" smtClean="0"/>
-              <a:t>28-11-2025</a:t>
+              <a:t>13-2-2026</a:t>
             </a:fld>
             <a:endParaRPr lang="nl-NL"/>
           </a:p>
@@ -5988,7 +5988,7 @@
           <a:p>
             <a:fld id="{4A37A092-F479-4C17-8DAB-26C19D8DEF50}" type="datetimeFigureOut">
               <a:rPr lang="nl-NL" smtClean="0"/>
-              <a:t>28-11-2025</a:t>
+              <a:t>13-2-2026</a:t>
             </a:fld>
             <a:endParaRPr lang="nl-NL"/>
           </a:p>
@@ -6165,7 +6165,7 @@
           <a:p>
             <a:fld id="{4A37A092-F479-4C17-8DAB-26C19D8DEF50}" type="datetimeFigureOut">
               <a:rPr lang="nl-NL" smtClean="0"/>
-              <a:t>28-11-2025</a:t>
+              <a:t>13-2-2026</a:t>
             </a:fld>
             <a:endParaRPr lang="nl-NL"/>
           </a:p>
@@ -6403,7 +6403,7 @@
           <a:p>
             <a:fld id="{4A37A092-F479-4C17-8DAB-26C19D8DEF50}" type="datetimeFigureOut">
               <a:rPr lang="nl-NL" smtClean="0"/>
-              <a:t>28-11-2025</a:t>
+              <a:t>13-2-2026</a:t>
             </a:fld>
             <a:endParaRPr lang="nl-NL"/>
           </a:p>
@@ -6603,7 +6603,7 @@
           <a:p>
             <a:fld id="{4A37A092-F479-4C17-8DAB-26C19D8DEF50}" type="datetimeFigureOut">
               <a:rPr lang="nl-NL" smtClean="0"/>
-              <a:t>28-11-2025</a:t>
+              <a:t>13-2-2026</a:t>
             </a:fld>
             <a:endParaRPr lang="nl-NL"/>
           </a:p>
@@ -6879,7 +6879,7 @@
           <a:p>
             <a:fld id="{4A37A092-F479-4C17-8DAB-26C19D8DEF50}" type="datetimeFigureOut">
               <a:rPr lang="nl-NL" smtClean="0"/>
-              <a:t>28-11-2025</a:t>
+              <a:t>13-2-2026</a:t>
             </a:fld>
             <a:endParaRPr lang="nl-NL"/>
           </a:p>
@@ -7145,7 +7145,7 @@
           <a:p>
             <a:fld id="{4A37A092-F479-4C17-8DAB-26C19D8DEF50}" type="datetimeFigureOut">
               <a:rPr lang="nl-NL" smtClean="0"/>
-              <a:t>28-11-2025</a:t>
+              <a:t>13-2-2026</a:t>
             </a:fld>
             <a:endParaRPr lang="nl-NL"/>
           </a:p>
@@ -7519,7 +7519,7 @@
           <a:p>
             <a:fld id="{4A37A092-F479-4C17-8DAB-26C19D8DEF50}" type="datetimeFigureOut">
               <a:rPr lang="nl-NL" smtClean="0"/>
-              <a:t>28-11-2025</a:t>
+              <a:t>13-2-2026</a:t>
             </a:fld>
             <a:endParaRPr lang="nl-NL"/>
           </a:p>
@@ -7667,7 +7667,7 @@
           <a:p>
             <a:fld id="{4A37A092-F479-4C17-8DAB-26C19D8DEF50}" type="datetimeFigureOut">
               <a:rPr lang="nl-NL" smtClean="0"/>
-              <a:t>28-11-2025</a:t>
+              <a:t>13-2-2026</a:t>
             </a:fld>
             <a:endParaRPr lang="nl-NL"/>
           </a:p>
@@ -7792,7 +7792,7 @@
           <a:p>
             <a:fld id="{4A37A092-F479-4C17-8DAB-26C19D8DEF50}" type="datetimeFigureOut">
               <a:rPr lang="nl-NL" smtClean="0"/>
-              <a:t>28-11-2025</a:t>
+              <a:t>13-2-2026</a:t>
             </a:fld>
             <a:endParaRPr lang="nl-NL"/>
           </a:p>
@@ -8077,7 +8077,7 @@
           <a:p>
             <a:fld id="{4A37A092-F479-4C17-8DAB-26C19D8DEF50}" type="datetimeFigureOut">
               <a:rPr lang="nl-NL" smtClean="0"/>
-              <a:t>28-11-2025</a:t>
+              <a:t>13-2-2026</a:t>
             </a:fld>
             <a:endParaRPr lang="nl-NL"/>
           </a:p>
@@ -8401,7 +8401,7 @@
           <a:p>
             <a:fld id="{4A37A092-F479-4C17-8DAB-26C19D8DEF50}" type="datetimeFigureOut">
               <a:rPr lang="nl-NL" smtClean="0"/>
-              <a:t>28-11-2025</a:t>
+              <a:t>13-2-2026</a:t>
             </a:fld>
             <a:endParaRPr lang="nl-NL"/>
           </a:p>
@@ -8615,7 +8615,7 @@
           <a:p>
             <a:fld id="{4A37A092-F479-4C17-8DAB-26C19D8DEF50}" type="datetimeFigureOut">
               <a:rPr lang="nl-NL" smtClean="0"/>
-              <a:t>28-11-2025</a:t>
+              <a:t>13-2-2026</a:t>
             </a:fld>
             <a:endParaRPr lang="nl-NL"/>
           </a:p>
@@ -10360,12 +10360,11 @@
 </file>
 
 <file path=customXml/item1.xml><?xml version="1.0" encoding="utf-8"?>
-<?mso-contentType ?>
-<FormTemplates xmlns="http://schemas.microsoft.com/sharepoint/v3/contenttype/forms">
-  <Display>DocumentLibraryForm</Display>
-  <Edit>DocumentLibraryForm</Edit>
-  <New>DocumentLibraryForm</New>
-</FormTemplates>
+<p:properties xmlns:p="http://schemas.microsoft.com/office/2006/metadata/properties" xmlns:xsi="http://www.w3.org/2001/XMLSchema-instance" xmlns:pc="http://schemas.microsoft.com/office/infopath/2007/PartnerControls">
+  <documentManagement>
+    <_activity xmlns="8d5dcd13-9b93-4860-8686-258dec0e23be" xsi:nil="true"/>
+  </documentManagement>
+</p:properties>
 </file>
 
 <file path=customXml/item2.xml><?xml version="1.0" encoding="utf-8"?>
@@ -10563,17 +10562,26 @@
 </file>
 
 <file path=customXml/item3.xml><?xml version="1.0" encoding="utf-8"?>
-<p:properties xmlns:p="http://schemas.microsoft.com/office/2006/metadata/properties" xmlns:xsi="http://www.w3.org/2001/XMLSchema-instance" xmlns:pc="http://schemas.microsoft.com/office/infopath/2007/PartnerControls">
-  <documentManagement>
-    <_activity xmlns="8d5dcd13-9b93-4860-8686-258dec0e23be" xsi:nil="true"/>
-  </documentManagement>
-</p:properties>
+<?mso-contentType ?>
+<FormTemplates xmlns="http://schemas.microsoft.com/sharepoint/v3/contenttype/forms">
+  <Display>DocumentLibraryForm</Display>
+  <Edit>DocumentLibraryForm</Edit>
+  <New>DocumentLibraryForm</New>
+</FormTemplates>
 </file>
 
 <file path=customXml/itemProps1.xml><?xml version="1.0" encoding="utf-8"?>
-<ds:datastoreItem xmlns:ds="http://schemas.openxmlformats.org/officeDocument/2006/customXml" ds:itemID="{33D4CFAA-434D-4462-B62D-1E23E4045646}">
+<ds:datastoreItem xmlns:ds="http://schemas.openxmlformats.org/officeDocument/2006/customXml" ds:itemID="{6BE63DC0-0E79-4D45-AB99-081F8145E24C}">
   <ds:schemaRefs>
-    <ds:schemaRef ds:uri="http://schemas.microsoft.com/sharepoint/v3/contenttype/forms"/>
+    <ds:schemaRef ds:uri="http://purl.org/dc/terms/"/>
+    <ds:schemaRef ds:uri="http://schemas.microsoft.com/office/infopath/2007/PartnerControls"/>
+    <ds:schemaRef ds:uri="http://schemas.openxmlformats.org/package/2006/metadata/core-properties"/>
+    <ds:schemaRef ds:uri="http://purl.org/dc/elements/1.1/"/>
+    <ds:schemaRef ds:uri="http://schemas.microsoft.com/office/2006/documentManagement/types"/>
+    <ds:schemaRef ds:uri="http://www.w3.org/XML/1998/namespace"/>
+    <ds:schemaRef ds:uri="8d5dcd13-9b93-4860-8686-258dec0e23be"/>
+    <ds:schemaRef ds:uri="http://schemas.microsoft.com/office/2006/metadata/properties"/>
+    <ds:schemaRef ds:uri="http://purl.org/dc/dcmitype/"/>
   </ds:schemaRefs>
 </ds:datastoreItem>
 </file>
@@ -10597,17 +10605,9 @@
 </file>
 
 <file path=customXml/itemProps3.xml><?xml version="1.0" encoding="utf-8"?>
-<ds:datastoreItem xmlns:ds="http://schemas.openxmlformats.org/officeDocument/2006/customXml" ds:itemID="{6BE63DC0-0E79-4D45-AB99-081F8145E24C}">
+<ds:datastoreItem xmlns:ds="http://schemas.openxmlformats.org/officeDocument/2006/customXml" ds:itemID="{33D4CFAA-434D-4462-B62D-1E23E4045646}">
   <ds:schemaRefs>
-    <ds:schemaRef ds:uri="http://purl.org/dc/terms/"/>
-    <ds:schemaRef ds:uri="http://schemas.microsoft.com/office/infopath/2007/PartnerControls"/>
-    <ds:schemaRef ds:uri="http://schemas.openxmlformats.org/package/2006/metadata/core-properties"/>
-    <ds:schemaRef ds:uri="http://purl.org/dc/elements/1.1/"/>
-    <ds:schemaRef ds:uri="http://schemas.microsoft.com/office/2006/documentManagement/types"/>
-    <ds:schemaRef ds:uri="http://www.w3.org/XML/1998/namespace"/>
-    <ds:schemaRef ds:uri="8d5dcd13-9b93-4860-8686-258dec0e23be"/>
-    <ds:schemaRef ds:uri="http://schemas.microsoft.com/office/2006/metadata/properties"/>
-    <ds:schemaRef ds:uri="http://purl.org/dc/dcmitype/"/>
+    <ds:schemaRef ds:uri="http://schemas.microsoft.com/sharepoint/v3/contenttype/forms"/>
   </ds:schemaRefs>
 </ds:datastoreItem>
 </file>
</xml_diff>